<commit_message>
Session 2 debrief: clearer blorps ask, drop the week-later blorps retest, spare pens, Menti demo prompt
- Blorps slide: both groups keep going until time's up; read the top of your sheet
- Retest: swap and score on the day; Session 3 (and the one-day afternoon) just asks
  "who remembers what a blorp is?" out loud; no slips kept, no blorps in the 1-week email
- Ranking: don't reopen Menti in Make 10 minutes active
- Menti demo slide gets a clickable mentimeter.com link; skip it if short, never the ask
- Pens: asked for in the pre-Session 2 message; facilitator brings spares
- One-day decks rebuilt

Co-Authored-By: Claude Sonnet 5.5 <noreply@anthropic.com>
</commit_message>
<xml_diff>
--- a/site/public/slides/ttl-day2-active-beats-passive.pptx
+++ b/site/public/slides/ttl-day2-active-beats-passive.pptx
@@ -491,7 +491,7 @@
           </a:p>
           <a:p>
             <a:r>
-              <a:t>  Back to the ranking from the Menti tour (show the result). That's what we FEEL helps. Research puts them in an order: listening, then doing something with it, then explaining it in your own words, then working it through together. The more people do with an idea, the more they tend to learn.</a:t>
+              <a:t>  Earlier you told me what you FEEL helps (no need to go back to Menti). Research puts them in an order: listening, then doing something with it, then explaining it in your own words, then working it through together. The more people do with an idea, the more they tend to learn.</a:t>
             </a:r>
           </a:p>
           <a:p>
@@ -728,7 +728,7 @@
           </a:p>
           <a:p>
             <a:r>
-              <a:t>  DEMO live, narrating each click: sign in → new presentation → one word-cloud slide → Share → copy link.</a:t>
+              <a:t>  DEMO only if there's time (skip it otherwise: 'the steps are on your task sheet'). Click the mentimeter.com link on the slide → sign in → New presentation → one word-cloud slide → Share → copy the link. Narrate each click.</a:t>
             </a:r>
           </a:p>
         </p:txBody>
@@ -1474,7 +1474,7 @@
           </a:p>
           <a:p>
             <a:r>
-              <a:t>  Eight important clinical terms you'll need later. (Deadpan.) Three minutes. Follow the instructions on YOUR sheet.</a:t>
+              <a:t>  Eight important clinical terms you'll need later. (Deadpan.) Three minutes. Read the top of your sheet and do what it says. Both groups keep going till time's up.</a:t>
             </a:r>
           </a:p>
           <a:p>
@@ -1600,7 +1600,7 @@
           </a:p>
           <a:p>
             <a:r>
-              <a:t>  Keep the ranking result for 'Make 10 minutes active'. Don't explain it yet.</a:t>
+              <a:t>  Mention once, in passing, that this is what THEY feel helps. Don't explain the research yet, and don't reopen Menti later.</a:t>
             </a:r>
           </a:p>
           <a:p>
@@ -1691,7 +1691,7 @@
           </a:p>
           <a:p>
             <a:r>
-              <a:t>  If A wins: 're-reading FEELS better, and today it works. Watch what happens over a week.'</a:t>
+              <a:t>  If A wins: 're-reading FEELS better, and today it works. The research says that fades over days.'</a:t>
             </a:r>
           </a:p>
           <a:p>
@@ -1716,7 +1716,7 @@
           </a:p>
           <a:p>
             <a:r>
-              <a:t>  Collect the slips, names on. Keep them for Day 3.</a:t>
+              <a:t>  Then swap with a neighbour, read the answers out, they score. Slips aren't kept: Day 3 asks 'who remembers what a blorp is?' out loud.</a:t>
             </a:r>
           </a:p>
         </p:txBody>
@@ -6160,6 +6160,19 @@
                 <a:latin typeface="Aptos"/>
               </a:rPr>
               <a:t>Same steps: Computer Task Sheet</a:t>
+            </a:r>
+          </a:p>
+          <a:p>
+            <a:pPr algn="ctr"/>
+            <a:r>
+              <a:rPr sz="2800" b="0">
+                <a:solidFill>
+                  <a:srgbClr val="4C4F69"/>
+                </a:solidFill>
+                <a:latin typeface="Aptos"/>
+                <a:hlinkClick r:id="rId4"/>
+              </a:rPr>
+              <a:t>mentimeter.com</a:t>
             </a:r>
           </a:p>
         </p:txBody>
@@ -9064,25 +9077,7 @@
                 </a:solidFill>
                 <a:latin typeface="Aptos"/>
               </a:rPr>
-              <a:t>Read the list</a:t>
-            </a:r>
-            <a:r>
-              <a:rPr lang="en-GB" sz="2800" b="1" dirty="0">
-                <a:solidFill>
-                  <a:srgbClr val="4C4F69"/>
-                </a:solidFill>
-                <a:latin typeface="Aptos"/>
-              </a:rPr>
-              <a:t> (don’t fold)</a:t>
-            </a:r>
-            <a:r>
-              <a:rPr sz="2800" b="1" dirty="0">
-                <a:solidFill>
-                  <a:srgbClr val="4C4F69"/>
-                </a:solidFill>
-                <a:latin typeface="Aptos"/>
-              </a:rPr>
-              <a:t>.</a:t>
+              <a:t>Read the list.</a:t>
             </a:r>
             <a:endParaRPr lang="en-GB" sz="2800" b="1" dirty="0">
               <a:solidFill>
@@ -9100,16 +9095,7 @@
                 </a:solidFill>
                 <a:latin typeface="Aptos"/>
               </a:rPr>
-              <a:t>Read a</a:t>
-            </a:r>
-            <a:r>
-              <a:rPr sz="2800" b="1" dirty="0">
-                <a:solidFill>
-                  <a:srgbClr val="4C4F69"/>
-                </a:solidFill>
-                <a:latin typeface="Aptos"/>
-              </a:rPr>
-              <a:t>gain.</a:t>
+              <a:t>Read it again.</a:t>
             </a:r>
             <a:endParaRPr lang="en-GB" sz="2800" b="1" dirty="0">
               <a:solidFill>
@@ -9127,7 +9113,7 @@
                 </a:solidFill>
                 <a:latin typeface="Aptos"/>
               </a:rPr>
-              <a:t>And again.</a:t>
+              <a:t>Keep going till time's up.</a:t>
             </a:r>
           </a:p>
         </p:txBody>
@@ -9196,7 +9182,7 @@
                 </a:solidFill>
                 <a:latin typeface="Aptos"/>
               </a:rPr>
-              <a:t>Read once.</a:t>
+              <a:t>Read it once.</a:t>
             </a:r>
             <a:endParaRPr lang="en-GB" sz="2800" b="1" dirty="0">
               <a:solidFill>
@@ -9214,25 +9200,7 @@
                 </a:solidFill>
                 <a:latin typeface="Aptos"/>
               </a:rPr>
-              <a:t>Fold it</a:t>
-            </a:r>
-            <a:r>
-              <a:rPr lang="en-GB" sz="2800" b="1" dirty="0">
-                <a:solidFill>
-                  <a:srgbClr val="4C4F69"/>
-                </a:solidFill>
-                <a:latin typeface="Aptos"/>
-              </a:rPr>
-              <a:t>. T</a:t>
-            </a:r>
-            <a:r>
-              <a:rPr sz="2800" b="1" dirty="0">
-                <a:solidFill>
-                  <a:srgbClr val="4C4F69"/>
-                </a:solidFill>
-                <a:latin typeface="Aptos"/>
-              </a:rPr>
-              <a:t>est yourself.</a:t>
+              <a:t>Fold it. Test yourself.</a:t>
             </a:r>
             <a:endParaRPr lang="en-GB" sz="2800" b="1" dirty="0">
               <a:solidFill>
@@ -9250,7 +9218,7 @@
                 </a:solidFill>
                 <a:latin typeface="Aptos"/>
               </a:rPr>
-              <a:t>Repeat this once.</a:t>
+              <a:t>Keep testing till time's up.</a:t>
             </a:r>
             <a:endParaRPr sz="2800" b="1" dirty="0">
               <a:solidFill>
@@ -9300,7 +9268,7 @@
                 </a:solidFill>
                 <a:latin typeface="Aptos"/>
               </a:rPr>
-              <a:t>  follow the instructions on your sheet</a:t>
+              <a:t>  read the top of your sheet and do what it says</a:t>
             </a:r>
           </a:p>
         </p:txBody>

</xml_diff>

<commit_message>
Session 2 debrief: clearer blorps ask, drop the week-later blorps retest, spare pens, Menti demo prompt (#28)
- Blorps slide: both groups keep going until time's up; read the top of your sheet
- Retest: swap and score on the day; Session 3 (and the one-day afternoon) just asks
  "who remembers what a blorp is?" out loud; no slips kept, no blorps in the 1-week email
- Ranking: don't reopen Menti in Make 10 minutes active
- Menti demo slide gets a clickable mentimeter.com link; skip it if short, never the ask
- Pens: asked for in the pre-Session 2 message; facilitator brings spares
- One-day decks rebuilt

Co-authored-by: Claude Sonnet 5.5 <noreply@anthropic.com>
</commit_message>
<xml_diff>
--- a/site/public/slides/ttl-day2-active-beats-passive.pptx
+++ b/site/public/slides/ttl-day2-active-beats-passive.pptx
@@ -491,7 +491,7 @@
           </a:p>
           <a:p>
             <a:r>
-              <a:t>  Back to the ranking from the Menti tour (show the result). That's what we FEEL helps. Research puts them in an order: listening, then doing something with it, then explaining it in your own words, then working it through together. The more people do with an idea, the more they tend to learn.</a:t>
+              <a:t>  Earlier you told me what you FEEL helps (no need to go back to Menti). Research puts them in an order: listening, then doing something with it, then explaining it in your own words, then working it through together. The more people do with an idea, the more they tend to learn.</a:t>
             </a:r>
           </a:p>
           <a:p>
@@ -728,7 +728,7 @@
           </a:p>
           <a:p>
             <a:r>
-              <a:t>  DEMO live, narrating each click: sign in → new presentation → one word-cloud slide → Share → copy link.</a:t>
+              <a:t>  DEMO only if there's time (skip it otherwise: 'the steps are on your task sheet'). Click the mentimeter.com link on the slide → sign in → New presentation → one word-cloud slide → Share → copy the link. Narrate each click.</a:t>
             </a:r>
           </a:p>
         </p:txBody>
@@ -1474,7 +1474,7 @@
           </a:p>
           <a:p>
             <a:r>
-              <a:t>  Eight important clinical terms you'll need later. (Deadpan.) Three minutes. Follow the instructions on YOUR sheet.</a:t>
+              <a:t>  Eight important clinical terms you'll need later. (Deadpan.) Three minutes. Read the top of your sheet and do what it says. Both groups keep going till time's up.</a:t>
             </a:r>
           </a:p>
           <a:p>
@@ -1600,7 +1600,7 @@
           </a:p>
           <a:p>
             <a:r>
-              <a:t>  Keep the ranking result for 'Make 10 minutes active'. Don't explain it yet.</a:t>
+              <a:t>  Mention once, in passing, that this is what THEY feel helps. Don't explain the research yet, and don't reopen Menti later.</a:t>
             </a:r>
           </a:p>
           <a:p>
@@ -1691,7 +1691,7 @@
           </a:p>
           <a:p>
             <a:r>
-              <a:t>  If A wins: 're-reading FEELS better, and today it works. Watch what happens over a week.'</a:t>
+              <a:t>  If A wins: 're-reading FEELS better, and today it works. The research says that fades over days.'</a:t>
             </a:r>
           </a:p>
           <a:p>
@@ -1716,7 +1716,7 @@
           </a:p>
           <a:p>
             <a:r>
-              <a:t>  Collect the slips, names on. Keep them for Day 3.</a:t>
+              <a:t>  Then swap with a neighbour, read the answers out, they score. Slips aren't kept: Day 3 asks 'who remembers what a blorp is?' out loud.</a:t>
             </a:r>
           </a:p>
         </p:txBody>
@@ -6160,6 +6160,19 @@
                 <a:latin typeface="Aptos"/>
               </a:rPr>
               <a:t>Same steps: Computer Task Sheet</a:t>
+            </a:r>
+          </a:p>
+          <a:p>
+            <a:pPr algn="ctr"/>
+            <a:r>
+              <a:rPr sz="2800" b="0">
+                <a:solidFill>
+                  <a:srgbClr val="4C4F69"/>
+                </a:solidFill>
+                <a:latin typeface="Aptos"/>
+                <a:hlinkClick r:id="rId4"/>
+              </a:rPr>
+              <a:t>mentimeter.com</a:t>
             </a:r>
           </a:p>
         </p:txBody>
@@ -9064,25 +9077,7 @@
                 </a:solidFill>
                 <a:latin typeface="Aptos"/>
               </a:rPr>
-              <a:t>Read the list</a:t>
-            </a:r>
-            <a:r>
-              <a:rPr lang="en-GB" sz="2800" b="1" dirty="0">
-                <a:solidFill>
-                  <a:srgbClr val="4C4F69"/>
-                </a:solidFill>
-                <a:latin typeface="Aptos"/>
-              </a:rPr>
-              <a:t> (don’t fold)</a:t>
-            </a:r>
-            <a:r>
-              <a:rPr sz="2800" b="1" dirty="0">
-                <a:solidFill>
-                  <a:srgbClr val="4C4F69"/>
-                </a:solidFill>
-                <a:latin typeface="Aptos"/>
-              </a:rPr>
-              <a:t>.</a:t>
+              <a:t>Read the list.</a:t>
             </a:r>
             <a:endParaRPr lang="en-GB" sz="2800" b="1" dirty="0">
               <a:solidFill>
@@ -9100,16 +9095,7 @@
                 </a:solidFill>
                 <a:latin typeface="Aptos"/>
               </a:rPr>
-              <a:t>Read a</a:t>
-            </a:r>
-            <a:r>
-              <a:rPr sz="2800" b="1" dirty="0">
-                <a:solidFill>
-                  <a:srgbClr val="4C4F69"/>
-                </a:solidFill>
-                <a:latin typeface="Aptos"/>
-              </a:rPr>
-              <a:t>gain.</a:t>
+              <a:t>Read it again.</a:t>
             </a:r>
             <a:endParaRPr lang="en-GB" sz="2800" b="1" dirty="0">
               <a:solidFill>
@@ -9127,7 +9113,7 @@
                 </a:solidFill>
                 <a:latin typeface="Aptos"/>
               </a:rPr>
-              <a:t>And again.</a:t>
+              <a:t>Keep going till time's up.</a:t>
             </a:r>
           </a:p>
         </p:txBody>
@@ -9196,7 +9182,7 @@
                 </a:solidFill>
                 <a:latin typeface="Aptos"/>
               </a:rPr>
-              <a:t>Read once.</a:t>
+              <a:t>Read it once.</a:t>
             </a:r>
             <a:endParaRPr lang="en-GB" sz="2800" b="1" dirty="0">
               <a:solidFill>
@@ -9214,25 +9200,7 @@
                 </a:solidFill>
                 <a:latin typeface="Aptos"/>
               </a:rPr>
-              <a:t>Fold it</a:t>
-            </a:r>
-            <a:r>
-              <a:rPr lang="en-GB" sz="2800" b="1" dirty="0">
-                <a:solidFill>
-                  <a:srgbClr val="4C4F69"/>
-                </a:solidFill>
-                <a:latin typeface="Aptos"/>
-              </a:rPr>
-              <a:t>. T</a:t>
-            </a:r>
-            <a:r>
-              <a:rPr sz="2800" b="1" dirty="0">
-                <a:solidFill>
-                  <a:srgbClr val="4C4F69"/>
-                </a:solidFill>
-                <a:latin typeface="Aptos"/>
-              </a:rPr>
-              <a:t>est yourself.</a:t>
+              <a:t>Fold it. Test yourself.</a:t>
             </a:r>
             <a:endParaRPr lang="en-GB" sz="2800" b="1" dirty="0">
               <a:solidFill>
@@ -9250,7 +9218,7 @@
                 </a:solidFill>
                 <a:latin typeface="Aptos"/>
               </a:rPr>
-              <a:t>Repeat this once.</a:t>
+              <a:t>Keep testing till time's up.</a:t>
             </a:r>
             <a:endParaRPr sz="2800" b="1" dirty="0">
               <a:solidFill>
@@ -9300,7 +9268,7 @@
                 </a:solidFill>
                 <a:latin typeface="Aptos"/>
               </a:rPr>
-              <a:t>  follow the instructions on your sheet</a:t>
+              <a:t>  read the top of your sheet and do what it says</a:t>
             </a:r>
           </a:p>
         </p:txBody>

</xml_diff>

<commit_message>
Blorps: Flat and Fold, not Version A and B; no names on the slips
"Flat" (re-read) and "Fold" (self-test) say what each sheet does. Renamed
on the sheets, the facilitator tally, Day 2 slide 6 and its notes (whose
paper link now points at /papers/testing-beats-re-reading), and the
Session 2 and one-day guides. The retest slips ask only which sheet you
had: they're scored in the room and not kept, so a name adds nothing.
One-day decks rebuilt.

Co-Authored-By: Claude Opus 5.5 <noreply@anthropic.com>
</commit_message>
<xml_diff>
--- a/site/public/slides/ttl-day2-active-beats-passive.pptx
+++ b/site/public/slides/ttl-day2-active-beats-passive.pptx
@@ -1484,7 +1484,7 @@
           </a:p>
           <a:p>
             <a:r>
-              <a:t>  Nonsense words nod to Ebbinghaus's nonsense syllables. A vs B is re-reading vs retrieval practice (Roediger &amp; Karpicke 2006). → /papers/roediger-karpicke-2006</a:t>
+              <a:t>  Nonsense words nod to Ebbinghaus's nonsense syllables. Flat vs Fold is re-reading vs retrieval practice (Roediger &amp; Karpicke 2006). → /papers/testing-beats-re-reading</a:t>
             </a:r>
           </a:p>
           <a:p>
@@ -1494,7 +1494,7 @@
           </a:p>
           <a:p>
             <a:r>
-              <a:t>  Hand out word sheets: half Version A, half Version B (alternate seats so groups mix).</a:t>
+              <a:t>  Hand out word sheets: half Flat, half Fold (alternate seats so groups mix).</a:t>
             </a:r>
           </a:p>
           <a:p>
@@ -1691,12 +1691,12 @@
           </a:p>
           <a:p>
             <a:r>
-              <a:t>  If A wins: 're-reading FEELS better, and today it works. The research says that fades over days.'</a:t>
-            </a:r>
-          </a:p>
-          <a:p>
-            <a:r>
-              <a:t>  If B wins: 'already. Now imagine a week.'</a:t>
+              <a:t>  If Flat wins: 're-reading FEELS better, and today it works. The research says that fades over days.'</a:t>
+            </a:r>
+          </a:p>
+          <a:p>
+            <a:r>
+              <a:t>  If Fold wins: 'already. Now imagine a week.'</a:t>
             </a:r>
           </a:p>
           <a:p>
@@ -1706,7 +1706,7 @@
           </a:p>
           <a:p>
             <a:r>
-              <a:t>  Hand out retest slips. Score 1 per meaning roughly right. Tally A vs B on the whiteboard.</a:t>
+              <a:t>  Hand out retest slips. Score 1 per meaning roughly right. Tally Flat vs Fold on the whiteboard.</a:t>
             </a:r>
           </a:p>
           <a:p>
@@ -9065,7 +9065,7 @@
                 </a:solidFill>
                 <a:latin typeface="Aptos"/>
               </a:rPr>
-              <a:t>Group A</a:t>
+              <a:t>Flat</a:t>
             </a:r>
           </a:p>
           <a:p>
@@ -9170,7 +9170,7 @@
                 </a:solidFill>
                 <a:latin typeface="Aptos"/>
               </a:rPr>
-              <a:t>Group B</a:t>
+              <a:t>Fold</a:t>
             </a:r>
           </a:p>
           <a:p>

</xml_diff>